<commit_message>
Add OP Memo 26-370 to SDG 15 evidence and update team deck
New memo found in the focal person's mailbox adopts the University Environmental
Compliance and Pollution Prevention Program with a PCB equipment procedure; added under
15.4.3 and 15.4.1 as continuing implementation. Checklist, inventory and deck updated
with the mailbox and web sweep results for the remaining indicators.

Co-Authored-By: Claude Sonnet 5.5 <noreply@anthropic.com>
Claude-Session: https://claude.ai/code/session_01SyejiGXq1iCHrrx9kiYLkx
</commit_message>
<xml_diff>
--- a/submission/sdg15/team-update/SDG15_Team_Update_2026-10-30.pptx
+++ b/submission/sdg15/team-update/SDG15_Team_Update_2026-10-30.pptx
@@ -118,41 +118,41 @@
   <p:extLst>
     <p:ext uri="{521415D9-36F7-43E2-AB2F-B90AF26B5E84}">
       <p14:sectionLst xmlns:p14="http://schemas.microsoft.com/office/powerpoint/2010/main">
-        <p14:section name="Opening" id="{f0c0971c-5199-0f49-d610-cce016a43d3f}">
+        <p14:section name="Opening" id="{1b7a76c4-625c-c24f-5efc-84197293d962}">
           <p14:sldIdLst>
             <p14:sldId id="256"/>
           </p14:sldIdLst>
         </p14:section>
-        <p14:section name="Status" id="{f6381afc-3a14-7938-2fed-9819c443e1f8}">
+        <p14:section name="Status" id="{b1cac46e-ffee-8cbd-60c2-bc1eec2ebfa4}">
           <p14:sldIdLst>
             <p14:sldId id="257"/>
           </p14:sldIdLst>
         </p14:section>
-        <p14:section name="Method" id="{870b9718-e1a2-c197-d7a5-a260f6e5ada1}">
+        <p14:section name="Method" id="{836c8503-5cfd-bb30-58b8-413e450d80bb}">
           <p14:sldIdLst>
             <p14:sldId id="258"/>
             <p14:sldId id="259"/>
             <p14:sldId id="260"/>
           </p14:sldIdLst>
         </p14:section>
-        <p14:section name="Evidence" id="{39d09182-697e-496a-d200-4bf7577b4f0b}">
+        <p14:section name="Evidence" id="{8e14aedd-d039-8338-ecdd-ef9f87eb9394}">
           <p14:sldIdLst>
             <p14:sldId id="261"/>
           </p14:sldIdLst>
         </p14:section>
-        <p14:section name="Benchmark" id="{b970dadb-1522-9dcb-bf66-b3c11f84762b}">
+        <p14:section name="Benchmark" id="{e0823683-2223-c525-6c9a-7aaeae1a48a5}">
           <p14:sldIdLst>
             <p14:sldId id="262"/>
             <p14:sldId id="263"/>
           </p14:sldIdLst>
         </p14:section>
-        <p14:section name="Findings" id="{169221b3-b0e5-7315-9c47-edfe5510be25}">
+        <p14:section name="Findings" id="{fa09bec6-0509-762e-a7de-99ba9082c845}">
           <p14:sldIdLst>
             <p14:sldId id="264"/>
             <p14:sldId id="265"/>
           </p14:sldIdLst>
         </p14:section>
-        <p14:section name="Actions" id="{6923ad73-8c27-aa8c-1087-64a9e833ed35}">
+        <p14:section name="Actions" id="{44ed3ff1-596f-0749-744f-1c498a2a6552}">
           <p14:sldIdLst>
             <p14:sldId id="266"/>
             <p14:sldId id="267"/>
@@ -4801,7 +4801,7 @@
                             <a:schemeClr val="tx1"/>
                           </a:solidFill>
                         </a:rPr>
-                        <a:t>A policy or programme for 15.2.2, 15.2.6, 15.3.2 and 15.3.4</a:t>
+                        <a:t>Search Facebook pages and memos for 15.2.2, 15.2.6, 15.3.2 and 15.3.4; draft a policy if none exists</a:t>
                       </a:r>
                       <a:endParaRPr lang="en-US" sz="1600" dirty="0"/>
                     </a:p>
@@ -6812,7 +6812,7 @@
                   <a:schemeClr val="tx1"/>
                 </a:solidFill>
               </a:rPr>
-              <a:t>Seven sweeps of MMSU's news archive (all 425 articles from 2025 read in full), SDG pages, Extension and Research sites, DOST-PCAARRD and news outlets.</a:t>
+              <a:t>Eight sweeps: MMSU's news archive (all 425 articles from 2025 read in full), SDG pages, the focal person's mailbox (memos, special orders), DOST-PCAARRD and news outlets.</a:t>
             </a:r>
             <a:endParaRPr lang="en-US" sz="1400" dirty="0"/>
           </a:p>
@@ -8073,7 +8073,7 @@
                   <a:schemeClr val="tx1"/>
                 </a:solidFill>
               </a:rPr>
-              <a:t>MMSU's site often failed, so pages were captured in a browser. Facebook posts behind a login could not be read.</a:t>
+              <a:t>MMSU's site often failed, so pages were captured in a browser. Facebook is behind a login and still has to be searched by a team member.</a:t>
             </a:r>
             <a:endParaRPr lang="en-US" sz="1500" dirty="0"/>
           </a:p>
@@ -11209,7 +11209,7 @@
                             <a:schemeClr val="tx1"/>
                           </a:solidFill>
                         </a:rPr>
-                        <a:t>Hazardous waste storage and disposal under the IPWMP</a:t>
+                        <a:t>Hazardous waste under the IPWMP; PCB procedure under the new compliance program</a:t>
                       </a:r>
                       <a:endParaRPr lang="en-US" sz="1600" dirty="0"/>
                     </a:p>
@@ -11270,7 +11270,7 @@
                             <a:schemeClr val="tx1"/>
                           </a:solidFill>
                         </a:rPr>
-                        <a:t>Revised 2020</a:t>
+                        <a:t>2020; Sep 2026</a:t>
                       </a:r>
                       <a:endParaRPr lang="en-US" sz="1600" dirty="0"/>
                     </a:p>

</xml_diff>